<commit_message>
PC DWWM - 15:14 - 28-04-26
</commit_message>
<xml_diff>
--- a/INTEGRATION/jour2/presentation/presentation projet.pptx
+++ b/INTEGRATION/jour2/presentation/presentation projet.pptx
@@ -123,277 +123,28 @@
 </p:presentation>
 </file>
 
-<file path=ppt/revisionInfo.xml><?xml version="1.0" encoding="utf-8"?>
-<p1510:revInfo xmlns:a="http://schemas.openxmlformats.org/drawingml/2006/main" xmlns:r="http://schemas.openxmlformats.org/officeDocument/2006/relationships" xmlns:p1510="http://schemas.microsoft.com/office/powerpoint/2015/10/main">
-  <p1510:revLst>
-    <p1510:client id="{8100E0E1-CCBB-4DD6-A081-52A2AED47616}" v="2" dt="2026-03-23T12:14:20.447"/>
-  </p1510:revLst>
-</p1510:revInfo>
-</file>
-
 <file path=ppt/changesInfos/changesInfo1.xml><?xml version="1.0" encoding="utf-8"?>
 <pc:chgInfo xmlns:a="http://schemas.openxmlformats.org/drawingml/2006/main" xmlns:r="http://schemas.openxmlformats.org/officeDocument/2006/relationships" xmlns:ac="http://schemas.microsoft.com/office/drawing/2013/main/command" xmlns:pc="http://schemas.microsoft.com/office/powerpoint/2013/main/command">
   <pc:docChgLst>
     <pc:chgData name="Aloe VERA" userId="6b960476-e567-467f-a33f-aec172a9bd13" providerId="ADAL" clId="{176D68A3-4BBE-457D-8FC1-C5809EB75CA7}"/>
-    <pc:docChg chg="custSel addSld modSld sldOrd">
-      <pc:chgData name="Aloe VERA" userId="6b960476-e567-467f-a33f-aec172a9bd13" providerId="ADAL" clId="{176D68A3-4BBE-457D-8FC1-C5809EB75CA7}" dt="2026-03-23T12:14:25.376" v="160" actId="21"/>
+    <pc:docChg chg="undo custSel addSld delSld modSld sldOrd">
+      <pc:chgData name="Aloe VERA" userId="6b960476-e567-467f-a33f-aec172a9bd13" providerId="ADAL" clId="{176D68A3-4BBE-457D-8FC1-C5809EB75CA7}" dt="2026-04-24T10:49:14.105" v="164" actId="2696"/>
       <pc:docMkLst>
         <pc:docMk/>
       </pc:docMkLst>
-      <pc:sldChg chg="modSp mod">
-        <pc:chgData name="Aloe VERA" userId="6b960476-e567-467f-a33f-aec172a9bd13" providerId="ADAL" clId="{176D68A3-4BBE-457D-8FC1-C5809EB75CA7}" dt="2026-03-23T12:07:44.461" v="15" actId="5793"/>
-        <pc:sldMkLst>
-          <pc:docMk/>
-          <pc:sldMk cId="3297414264" sldId="263"/>
-        </pc:sldMkLst>
-        <pc:spChg chg="mod">
-          <ac:chgData name="Aloe VERA" userId="6b960476-e567-467f-a33f-aec172a9bd13" providerId="ADAL" clId="{176D68A3-4BBE-457D-8FC1-C5809EB75CA7}" dt="2026-03-23T12:07:44.461" v="15" actId="5793"/>
-          <ac:spMkLst>
-            <pc:docMk/>
-            <pc:sldMk cId="3297414264" sldId="263"/>
-            <ac:spMk id="3" creationId="{409DDAFA-FA15-CBFA-5BD9-6FCDFC33BD2D}"/>
-          </ac:spMkLst>
-        </pc:spChg>
-      </pc:sldChg>
-      <pc:sldChg chg="addSp delSp modSp new mod ord">
-        <pc:chgData name="Aloe VERA" userId="6b960476-e567-467f-a33f-aec172a9bd13" providerId="ADAL" clId="{176D68A3-4BBE-457D-8FC1-C5809EB75CA7}" dt="2026-03-23T12:14:25.376" v="160" actId="21"/>
-        <pc:sldMkLst>
-          <pc:docMk/>
-          <pc:sldMk cId="1139302114" sldId="268"/>
-        </pc:sldMkLst>
-        <pc:spChg chg="del mod">
-          <ac:chgData name="Aloe VERA" userId="6b960476-e567-467f-a33f-aec172a9bd13" providerId="ADAL" clId="{176D68A3-4BBE-457D-8FC1-C5809EB75CA7}" dt="2026-03-23T12:10:04.653" v="48" actId="21"/>
-          <ac:spMkLst>
-            <pc:docMk/>
-            <pc:sldMk cId="1139302114" sldId="268"/>
-            <ac:spMk id="2" creationId="{53DBB9A4-30DB-5F1E-D39D-C4001ABB9BD5}"/>
-          </ac:spMkLst>
-        </pc:spChg>
-        <pc:spChg chg="del mod">
-          <ac:chgData name="Aloe VERA" userId="6b960476-e567-467f-a33f-aec172a9bd13" providerId="ADAL" clId="{176D68A3-4BBE-457D-8FC1-C5809EB75CA7}" dt="2026-03-23T12:10:01.852" v="47" actId="21"/>
-          <ac:spMkLst>
-            <pc:docMk/>
-            <pc:sldMk cId="1139302114" sldId="268"/>
-            <ac:spMk id="3" creationId="{77650664-3958-F1F2-452F-902934031CCF}"/>
-          </ac:spMkLst>
-        </pc:spChg>
-        <pc:spChg chg="add mod">
-          <ac:chgData name="Aloe VERA" userId="6b960476-e567-467f-a33f-aec172a9bd13" providerId="ADAL" clId="{176D68A3-4BBE-457D-8FC1-C5809EB75CA7}" dt="2026-03-23T12:13:43.007" v="158" actId="20577"/>
-          <ac:spMkLst>
-            <pc:docMk/>
-            <pc:sldMk cId="1139302114" sldId="268"/>
-            <ac:spMk id="4" creationId="{E7FEB623-D6A8-7998-E35A-7184DF2D2285}"/>
-          </ac:spMkLst>
-        </pc:spChg>
-        <pc:spChg chg="add del mod">
-          <ac:chgData name="Aloe VERA" userId="6b960476-e567-467f-a33f-aec172a9bd13" providerId="ADAL" clId="{176D68A3-4BBE-457D-8FC1-C5809EB75CA7}" dt="2026-03-23T12:14:25.376" v="160" actId="21"/>
-          <ac:spMkLst>
-            <pc:docMk/>
-            <pc:sldMk cId="1139302114" sldId="268"/>
-            <ac:spMk id="5" creationId="{2A20A02C-D38C-A980-27AC-3E4D37D0828B}"/>
-          </ac:spMkLst>
-        </pc:spChg>
-      </pc:sldChg>
-    </pc:docChg>
-  </pc:docChgLst>
-  <pc:docChgLst>
-    <pc:chgData name="administrateur mayotte" userId="c34775b3-b886-4d0e-befd-463d6332c73f" providerId="ADAL" clId="{7B4C5FFD-071D-4A95-81DB-8595EC327B9E}"/>
-    <pc:docChg chg="modSld">
-      <pc:chgData name="administrateur mayotte" userId="c34775b3-b886-4d0e-befd-463d6332c73f" providerId="ADAL" clId="{7B4C5FFD-071D-4A95-81DB-8595EC327B9E}" dt="2026-03-06T08:44:22.868" v="4" actId="1037"/>
-      <pc:docMkLst>
-        <pc:docMk/>
-      </pc:docMkLst>
-      <pc:sldChg chg="modSp mod">
-        <pc:chgData name="administrateur mayotte" userId="c34775b3-b886-4d0e-befd-463d6332c73f" providerId="ADAL" clId="{7B4C5FFD-071D-4A95-81DB-8595EC327B9E}" dt="2026-03-06T08:44:22.868" v="4" actId="1037"/>
+      <pc:sldChg chg="add del">
+        <pc:chgData name="Aloe VERA" userId="6b960476-e567-467f-a33f-aec172a9bd13" providerId="ADAL" clId="{176D68A3-4BBE-457D-8FC1-C5809EB75CA7}" dt="2026-04-24T10:49:14.105" v="164" actId="2696"/>
         <pc:sldMkLst>
           <pc:docMk/>
           <pc:sldMk cId="1468464710" sldId="257"/>
         </pc:sldMkLst>
-        <pc:picChg chg="mod">
-          <ac:chgData name="administrateur mayotte" userId="c34775b3-b886-4d0e-befd-463d6332c73f" providerId="ADAL" clId="{7B4C5FFD-071D-4A95-81DB-8595EC327B9E}" dt="2026-03-06T08:44:22.868" v="4" actId="1037"/>
-          <ac:picMkLst>
-            <pc:docMk/>
-            <pc:sldMk cId="1468464710" sldId="257"/>
-            <ac:picMk id="4" creationId="{37DE5984-91A2-ED08-7F64-0EF38B99E622}"/>
-          </ac:picMkLst>
-        </pc:picChg>
       </pc:sldChg>
-    </pc:docChg>
-  </pc:docChgLst>
-  <pc:docChgLst>
-    <pc:chgData name="Aloe VERA" userId="6b960476-e567-467f-a33f-aec172a9bd13" providerId="ADAL" clId="{475237A9-C41C-45A2-BFB0-A29C4B8C8A85}"/>
-    <pc:docChg chg="undo custSel addSld delSld modSld">
-      <pc:chgData name="Aloe VERA" userId="6b960476-e567-467f-a33f-aec172a9bd13" providerId="ADAL" clId="{475237A9-C41C-45A2-BFB0-A29C4B8C8A85}" dt="2026-03-06T09:51:02.841" v="510" actId="313"/>
-      <pc:docMkLst>
-        <pc:docMk/>
-      </pc:docMkLst>
-      <pc:sldChg chg="addSp delSp modSp mod delDesignElem">
-        <pc:chgData name="Aloe VERA" userId="6b960476-e567-467f-a33f-aec172a9bd13" providerId="ADAL" clId="{475237A9-C41C-45A2-BFB0-A29C4B8C8A85}" dt="2026-03-06T05:21:09.553" v="109" actId="14100"/>
+      <pc:sldChg chg="add del">
+        <pc:chgData name="Aloe VERA" userId="6b960476-e567-467f-a33f-aec172a9bd13" providerId="ADAL" clId="{176D68A3-4BBE-457D-8FC1-C5809EB75CA7}" dt="2026-04-24T10:49:13.811" v="163" actId="2696"/>
         <pc:sldMkLst>
           <pc:docMk/>
-          <pc:sldMk cId="1468464710" sldId="257"/>
+          <pc:sldMk cId="509059419" sldId="258"/>
         </pc:sldMkLst>
-        <pc:spChg chg="mod">
-          <ac:chgData name="Aloe VERA" userId="6b960476-e567-467f-a33f-aec172a9bd13" providerId="ADAL" clId="{475237A9-C41C-45A2-BFB0-A29C4B8C8A85}" dt="2026-03-06T04:42:01.580" v="2" actId="27636"/>
-          <ac:spMkLst>
-            <pc:docMk/>
-            <pc:sldMk cId="1468464710" sldId="257"/>
-            <ac:spMk id="2" creationId="{432EB9DB-6C59-8C44-6840-A039DA5483B3}"/>
-          </ac:spMkLst>
-        </pc:spChg>
-        <pc:picChg chg="mod">
-          <ac:chgData name="Aloe VERA" userId="6b960476-e567-467f-a33f-aec172a9bd13" providerId="ADAL" clId="{475237A9-C41C-45A2-BFB0-A29C4B8C8A85}" dt="2026-03-06T05:19:49.843" v="104" actId="1076"/>
-          <ac:picMkLst>
-            <pc:docMk/>
-            <pc:sldMk cId="1468464710" sldId="257"/>
-            <ac:picMk id="4" creationId="{37DE5984-91A2-ED08-7F64-0EF38B99E622}"/>
-          </ac:picMkLst>
-        </pc:picChg>
-        <pc:picChg chg="add mod">
-          <ac:chgData name="Aloe VERA" userId="6b960476-e567-467f-a33f-aec172a9bd13" providerId="ADAL" clId="{475237A9-C41C-45A2-BFB0-A29C4B8C8A85}" dt="2026-03-06T05:21:09.553" v="109" actId="14100"/>
-          <ac:picMkLst>
-            <pc:docMk/>
-            <pc:sldMk cId="1468464710" sldId="257"/>
-            <ac:picMk id="5" creationId="{B85A0172-10A2-F4F0-E44E-71B1A5DCA700}"/>
-          </ac:picMkLst>
-        </pc:picChg>
-      </pc:sldChg>
-      <pc:sldChg chg="modSp mod">
-        <pc:chgData name="Aloe VERA" userId="6b960476-e567-467f-a33f-aec172a9bd13" providerId="ADAL" clId="{475237A9-C41C-45A2-BFB0-A29C4B8C8A85}" dt="2026-03-06T04:44:56.377" v="8" actId="14100"/>
-        <pc:sldMkLst>
-          <pc:docMk/>
-          <pc:sldMk cId="2729895418" sldId="260"/>
-        </pc:sldMkLst>
-        <pc:spChg chg="mod">
-          <ac:chgData name="Aloe VERA" userId="6b960476-e567-467f-a33f-aec172a9bd13" providerId="ADAL" clId="{475237A9-C41C-45A2-BFB0-A29C4B8C8A85}" dt="2026-03-06T04:44:56.377" v="8" actId="14100"/>
-          <ac:spMkLst>
-            <pc:docMk/>
-            <pc:sldMk cId="2729895418" sldId="260"/>
-            <ac:spMk id="2" creationId="{F5939F73-1940-569C-2A2E-B974CDAE6DC4}"/>
-          </ac:spMkLst>
-        </pc:spChg>
-      </pc:sldChg>
-      <pc:sldChg chg="modSp mod">
-        <pc:chgData name="Aloe VERA" userId="6b960476-e567-467f-a33f-aec172a9bd13" providerId="ADAL" clId="{475237A9-C41C-45A2-BFB0-A29C4B8C8A85}" dt="2026-03-06T05:29:45.811" v="140" actId="20577"/>
-        <pc:sldMkLst>
-          <pc:docMk/>
-          <pc:sldMk cId="164124010" sldId="261"/>
-        </pc:sldMkLst>
-        <pc:spChg chg="mod">
-          <ac:chgData name="Aloe VERA" userId="6b960476-e567-467f-a33f-aec172a9bd13" providerId="ADAL" clId="{475237A9-C41C-45A2-BFB0-A29C4B8C8A85}" dt="2026-03-06T04:43:02.956" v="4"/>
-          <ac:spMkLst>
-            <pc:docMk/>
-            <pc:sldMk cId="164124010" sldId="261"/>
-            <ac:spMk id="2" creationId="{913D826D-3430-3396-B3A9-43655C4E8F4F}"/>
-          </ac:spMkLst>
-        </pc:spChg>
-        <pc:spChg chg="mod">
-          <ac:chgData name="Aloe VERA" userId="6b960476-e567-467f-a33f-aec172a9bd13" providerId="ADAL" clId="{475237A9-C41C-45A2-BFB0-A29C4B8C8A85}" dt="2026-03-06T05:29:45.811" v="140" actId="20577"/>
-          <ac:spMkLst>
-            <pc:docMk/>
-            <pc:sldMk cId="164124010" sldId="261"/>
-            <ac:spMk id="3" creationId="{017D7245-1663-8BCC-2C5C-687D66BD5EA1}"/>
-          </ac:spMkLst>
-        </pc:spChg>
-      </pc:sldChg>
-      <pc:sldChg chg="modSp">
-        <pc:chgData name="Aloe VERA" userId="6b960476-e567-467f-a33f-aec172a9bd13" providerId="ADAL" clId="{475237A9-C41C-45A2-BFB0-A29C4B8C8A85}" dt="2026-03-06T04:43:02.956" v="4"/>
-        <pc:sldMkLst>
-          <pc:docMk/>
-          <pc:sldMk cId="3297414264" sldId="263"/>
-        </pc:sldMkLst>
-        <pc:spChg chg="mod">
-          <ac:chgData name="Aloe VERA" userId="6b960476-e567-467f-a33f-aec172a9bd13" providerId="ADAL" clId="{475237A9-C41C-45A2-BFB0-A29C4B8C8A85}" dt="2026-03-06T04:43:02.956" v="4"/>
-          <ac:spMkLst>
-            <pc:docMk/>
-            <pc:sldMk cId="3297414264" sldId="263"/>
-            <ac:spMk id="2" creationId="{718E76E8-EA3E-BD9D-FEBF-3D3A3C6AF738}"/>
-          </ac:spMkLst>
-        </pc:spChg>
-      </pc:sldChg>
-      <pc:sldChg chg="modSp mod">
-        <pc:chgData name="Aloe VERA" userId="6b960476-e567-467f-a33f-aec172a9bd13" providerId="ADAL" clId="{475237A9-C41C-45A2-BFB0-A29C4B8C8A85}" dt="2026-03-06T04:47:10.481" v="12" actId="14100"/>
-        <pc:sldMkLst>
-          <pc:docMk/>
-          <pc:sldMk cId="2162270180" sldId="264"/>
-        </pc:sldMkLst>
-        <pc:spChg chg="mod">
-          <ac:chgData name="Aloe VERA" userId="6b960476-e567-467f-a33f-aec172a9bd13" providerId="ADAL" clId="{475237A9-C41C-45A2-BFB0-A29C4B8C8A85}" dt="2026-03-06T04:47:10.481" v="12" actId="14100"/>
-          <ac:spMkLst>
-            <pc:docMk/>
-            <pc:sldMk cId="2162270180" sldId="264"/>
-            <ac:spMk id="2" creationId="{8814CE90-3ECC-14EC-8342-1265AD9E60C9}"/>
-          </ac:spMkLst>
-        </pc:spChg>
-      </pc:sldChg>
-      <pc:sldChg chg="modSp mod">
-        <pc:chgData name="Aloe VERA" userId="6b960476-e567-467f-a33f-aec172a9bd13" providerId="ADAL" clId="{475237A9-C41C-45A2-BFB0-A29C4B8C8A85}" dt="2026-03-06T09:51:02.841" v="510" actId="313"/>
-        <pc:sldMkLst>
-          <pc:docMk/>
-          <pc:sldMk cId="3223475225" sldId="265"/>
-        </pc:sldMkLst>
-        <pc:spChg chg="mod">
-          <ac:chgData name="Aloe VERA" userId="6b960476-e567-467f-a33f-aec172a9bd13" providerId="ADAL" clId="{475237A9-C41C-45A2-BFB0-A29C4B8C8A85}" dt="2026-03-06T04:43:02.956" v="4"/>
-          <ac:spMkLst>
-            <pc:docMk/>
-            <pc:sldMk cId="3223475225" sldId="265"/>
-            <ac:spMk id="2" creationId="{6CC55EDE-3C1E-668B-B6C8-09E533ABD6CC}"/>
-          </ac:spMkLst>
-        </pc:spChg>
-        <pc:spChg chg="mod">
-          <ac:chgData name="Aloe VERA" userId="6b960476-e567-467f-a33f-aec172a9bd13" providerId="ADAL" clId="{475237A9-C41C-45A2-BFB0-A29C4B8C8A85}" dt="2026-03-06T09:51:02.841" v="510" actId="313"/>
-          <ac:spMkLst>
-            <pc:docMk/>
-            <pc:sldMk cId="3223475225" sldId="265"/>
-            <ac:spMk id="3" creationId="{38AFF143-82A7-3C0A-4816-70C8BD6E9221}"/>
-          </ac:spMkLst>
-        </pc:spChg>
-      </pc:sldChg>
-      <pc:sldChg chg="modSp new mod modTransition">
-        <pc:chgData name="Aloe VERA" userId="6b960476-e567-467f-a33f-aec172a9bd13" providerId="ADAL" clId="{475237A9-C41C-45A2-BFB0-A29C4B8C8A85}" dt="2026-03-06T04:55:55.781" v="92"/>
-        <pc:sldMkLst>
-          <pc:docMk/>
-          <pc:sldMk cId="136567134" sldId="266"/>
-        </pc:sldMkLst>
-        <pc:spChg chg="mod">
-          <ac:chgData name="Aloe VERA" userId="6b960476-e567-467f-a33f-aec172a9bd13" providerId="ADAL" clId="{475237A9-C41C-45A2-BFB0-A29C4B8C8A85}" dt="2026-03-06T04:52:52.924" v="91" actId="20577"/>
-          <ac:spMkLst>
-            <pc:docMk/>
-            <pc:sldMk cId="136567134" sldId="266"/>
-            <ac:spMk id="2" creationId="{5E3BBAAF-D735-BBD3-84ED-E450D43BFFD8}"/>
-          </ac:spMkLst>
-        </pc:spChg>
-        <pc:spChg chg="mod">
-          <ac:chgData name="Aloe VERA" userId="6b960476-e567-467f-a33f-aec172a9bd13" providerId="ADAL" clId="{475237A9-C41C-45A2-BFB0-A29C4B8C8A85}" dt="2026-03-06T04:52:28.625" v="84" actId="1076"/>
-          <ac:spMkLst>
-            <pc:docMk/>
-            <pc:sldMk cId="136567134" sldId="266"/>
-            <ac:spMk id="3" creationId="{6F3E8BFE-CC4B-6E45-F5E6-F9457A0B533E}"/>
-          </ac:spMkLst>
-        </pc:spChg>
-      </pc:sldChg>
-      <pc:sldChg chg="addSp delSp modSp new mod modTransition setBg">
-        <pc:chgData name="Aloe VERA" userId="6b960476-e567-467f-a33f-aec172a9bd13" providerId="ADAL" clId="{475237A9-C41C-45A2-BFB0-A29C4B8C8A85}" dt="2026-03-06T08:32:47.813" v="176"/>
-        <pc:sldMkLst>
-          <pc:docMk/>
-          <pc:sldMk cId="2772443484" sldId="267"/>
-        </pc:sldMkLst>
-        <pc:spChg chg="mod">
-          <ac:chgData name="Aloe VERA" userId="6b960476-e567-467f-a33f-aec172a9bd13" providerId="ADAL" clId="{475237A9-C41C-45A2-BFB0-A29C4B8C8A85}" dt="2026-03-06T08:32:00.072" v="175" actId="14100"/>
-          <ac:spMkLst>
-            <pc:docMk/>
-            <pc:sldMk cId="2772443484" sldId="267"/>
-            <ac:spMk id="2" creationId="{1726C446-AED6-13AD-F848-2E502EAD770F}"/>
-          </ac:spMkLst>
-        </pc:spChg>
-        <pc:picChg chg="add mod ord">
-          <ac:chgData name="Aloe VERA" userId="6b960476-e567-467f-a33f-aec172a9bd13" providerId="ADAL" clId="{475237A9-C41C-45A2-BFB0-A29C4B8C8A85}" dt="2026-03-06T08:31:21.074" v="172" actId="1076"/>
-          <ac:picMkLst>
-            <pc:docMk/>
-            <pc:sldMk cId="2772443484" sldId="267"/>
-            <ac:picMk id="5" creationId="{59685F4C-EC2D-0BCB-5BB4-35E92F3DA68E}"/>
-          </ac:picMkLst>
-        </pc:picChg>
       </pc:sldChg>
     </pc:docChg>
   </pc:docChgLst>
@@ -588,7 +339,7 @@
           <a:p>
             <a:fld id="{E31BA835-12AC-4E8F-955A-EA3F4DE2791F}" type="datetime1">
               <a:rPr lang="en-US" smtClean="0"/>
-              <a:t>3/23/2026</a:t>
+              <a:t>4/24/2026</a:t>
             </a:fld>
             <a:endParaRPr lang="en-US"/>
           </a:p>
@@ -934,7 +685,7 @@
           <a:p>
             <a:fld id="{E31BA835-12AC-4E8F-955A-EA3F4DE2791F}" type="datetime1">
               <a:rPr lang="en-US" smtClean="0"/>
-              <a:t>3/23/2026</a:t>
+              <a:t>4/24/2026</a:t>
             </a:fld>
             <a:endParaRPr lang="en-US"/>
           </a:p>
@@ -1336,7 +1087,7 @@
           <a:p>
             <a:fld id="{E31BA835-12AC-4E8F-955A-EA3F4DE2791F}" type="datetime1">
               <a:rPr lang="en-US" smtClean="0"/>
-              <a:t>3/23/2026</a:t>
+              <a:t>4/24/2026</a:t>
             </a:fld>
             <a:endParaRPr lang="en-US"/>
           </a:p>
@@ -1673,7 +1424,7 @@
           <a:p>
             <a:fld id="{E31BA835-12AC-4E8F-955A-EA3F4DE2791F}" type="datetime1">
               <a:rPr lang="en-US" smtClean="0"/>
-              <a:t>3/23/2026</a:t>
+              <a:t>4/24/2026</a:t>
             </a:fld>
             <a:endParaRPr lang="en-US"/>
           </a:p>
@@ -1994,7 +1745,7 @@
           <a:p>
             <a:fld id="{E31BA835-12AC-4E8F-955A-EA3F4DE2791F}" type="datetime1">
               <a:rPr lang="en-US" smtClean="0"/>
-              <a:t>3/23/2026</a:t>
+              <a:t>4/24/2026</a:t>
             </a:fld>
             <a:endParaRPr lang="en-US"/>
           </a:p>
@@ -2391,7 +2142,7 @@
           <a:p>
             <a:fld id="{E31BA835-12AC-4E8F-955A-EA3F4DE2791F}" type="datetime1">
               <a:rPr lang="en-US" smtClean="0"/>
-              <a:t>3/23/2026</a:t>
+              <a:t>4/24/2026</a:t>
             </a:fld>
             <a:endParaRPr lang="en-US"/>
           </a:p>
@@ -2649,7 +2400,7 @@
           <a:p>
             <a:fld id="{E31BA835-12AC-4E8F-955A-EA3F4DE2791F}" type="datetime1">
               <a:rPr lang="en-US" smtClean="0"/>
-              <a:t>3/23/2026</a:t>
+              <a:t>4/24/2026</a:t>
             </a:fld>
             <a:endParaRPr lang="en-US"/>
           </a:p>
@@ -2912,7 +2663,7 @@
           <a:p>
             <a:fld id="{E31BA835-12AC-4E8F-955A-EA3F4DE2791F}" type="datetime1">
               <a:rPr lang="en-US" smtClean="0"/>
-              <a:t>3/23/2026</a:t>
+              <a:t>4/24/2026</a:t>
             </a:fld>
             <a:endParaRPr lang="en-US"/>
           </a:p>
@@ -3170,7 +2921,7 @@
           <a:p>
             <a:fld id="{E31BA835-12AC-4E8F-955A-EA3F4DE2791F}" type="datetime1">
               <a:rPr lang="en-US" smtClean="0"/>
-              <a:t>3/23/2026</a:t>
+              <a:t>4/24/2026</a:t>
             </a:fld>
             <a:endParaRPr lang="en-US"/>
           </a:p>
@@ -3351,7 +3102,7 @@
           <a:p>
             <a:fld id="{E31BA835-12AC-4E8F-955A-EA3F4DE2791F}" type="datetime1">
               <a:rPr lang="en-US" smtClean="0"/>
-              <a:t>3/23/2026</a:t>
+              <a:t>4/24/2026</a:t>
             </a:fld>
             <a:endParaRPr lang="en-US"/>
           </a:p>
@@ -3681,7 +3432,7 @@
           <a:p>
             <a:fld id="{E31BA835-12AC-4E8F-955A-EA3F4DE2791F}" type="datetime1">
               <a:rPr lang="en-US" smtClean="0"/>
-              <a:t>3/23/2026</a:t>
+              <a:t>4/24/2026</a:t>
             </a:fld>
             <a:endParaRPr lang="en-US"/>
           </a:p>
@@ -4005,7 +3756,7 @@
           <a:p>
             <a:fld id="{E31BA835-12AC-4E8F-955A-EA3F4DE2791F}" type="datetime1">
               <a:rPr lang="en-US" smtClean="0"/>
-              <a:t>3/23/2026</a:t>
+              <a:t>4/24/2026</a:t>
             </a:fld>
             <a:endParaRPr lang="en-US"/>
           </a:p>
@@ -4463,7 +4214,7 @@
           <a:p>
             <a:fld id="{E31BA835-12AC-4E8F-955A-EA3F4DE2791F}" type="datetime1">
               <a:rPr lang="en-US" smtClean="0"/>
-              <a:t>3/23/2026</a:t>
+              <a:t>4/24/2026</a:t>
             </a:fld>
             <a:endParaRPr lang="en-US"/>
           </a:p>
@@ -4669,7 +4420,7 @@
           <a:p>
             <a:fld id="{E31BA835-12AC-4E8F-955A-EA3F4DE2791F}" type="datetime1">
               <a:rPr lang="en-US" smtClean="0"/>
-              <a:t>3/23/2026</a:t>
+              <a:t>4/24/2026</a:t>
             </a:fld>
             <a:endParaRPr lang="en-US"/>
           </a:p>
@@ -4847,7 +4598,7 @@
           <a:p>
             <a:fld id="{E31BA835-12AC-4E8F-955A-EA3F4DE2791F}" type="datetime1">
               <a:rPr lang="en-US" smtClean="0"/>
-              <a:t>3/23/2026</a:t>
+              <a:t>4/24/2026</a:t>
             </a:fld>
             <a:endParaRPr lang="en-US"/>
           </a:p>
@@ -5181,7 +4932,7 @@
           <a:p>
             <a:fld id="{E31BA835-12AC-4E8F-955A-EA3F4DE2791F}" type="datetime1">
               <a:rPr lang="en-US" smtClean="0"/>
-              <a:t>3/23/2026</a:t>
+              <a:t>4/24/2026</a:t>
             </a:fld>
             <a:endParaRPr lang="en-US"/>
           </a:p>
@@ -5527,7 +5278,7 @@
           <a:p>
             <a:fld id="{E31BA835-12AC-4E8F-955A-EA3F4DE2791F}" type="datetime1">
               <a:rPr lang="en-US" smtClean="0"/>
-              <a:t>3/23/2026</a:t>
+              <a:t>4/24/2026</a:t>
             </a:fld>
             <a:endParaRPr lang="en-US"/>
           </a:p>
@@ -7820,7 +7571,7 @@
           <a:p>
             <a:fld id="{E31BA835-12AC-4E8F-955A-EA3F4DE2791F}" type="datetime1">
               <a:rPr lang="en-US" smtClean="0"/>
-              <a:t>3/23/2026</a:t>
+              <a:t>4/24/2026</a:t>
             </a:fld>
             <a:endParaRPr lang="en-US"/>
           </a:p>
@@ -8424,7 +8175,7 @@
           <a:p>
             <a:pPr algn="l"/>
             <a:r>
-              <a:rPr lang="fr-FR" sz="5600">
+              <a:rPr lang="fr-FR" sz="5600" dirty="0">
                 <a:solidFill>
                   <a:schemeClr val="tx1"/>
                 </a:solidFill>
@@ -8929,7 +8680,7 @@
           <a:lstStyle/>
           <a:p>
             <a:r>
-              <a:rPr lang="fr-FR" sz="2800"/>
+              <a:rPr lang="fr-FR" sz="2800" dirty="0"/>
               <a:t>Identification des problèmes</a:t>
             </a:r>
           </a:p>
@@ -9054,11 +8805,11 @@
               <a:buNone/>
             </a:pPr>
             <a:r>
-              <a:rPr lang="fr-FR"/>
+              <a:rPr lang="fr-FR" dirty="0"/>
               <a:t>ex</a:t>
             </a:r>
             <a:r>
-              <a:rPr lang="fr-FR">
+              <a:rPr lang="fr-FR" dirty="0">
                 <a:solidFill>
                   <a:schemeClr val="tx1">
                     <a:lumMod val="95000"/>
@@ -9068,14 +8819,14 @@
               </a:rPr>
               <a:t>:</a:t>
             </a:r>
-            <a:endParaRPr lang="fr-FR"/>
+            <a:endParaRPr lang="fr-FR" dirty="0"/>
           </a:p>
           <a:p>
             <a:pPr marL="0" indent="0">
               <a:buNone/>
             </a:pPr>
             <a:r>
-              <a:rPr lang="fr-FR"/>
+              <a:rPr lang="fr-FR" dirty="0"/>
               <a:t>. nettoyage</a:t>
             </a:r>
           </a:p>
@@ -9084,7 +8835,7 @@
               <a:buNone/>
             </a:pPr>
             <a:r>
-              <a:rPr lang="fr-FR"/>
+              <a:rPr lang="fr-FR" dirty="0"/>
               <a:t>. Jardinage</a:t>
             </a:r>
           </a:p>
@@ -9093,7 +8844,7 @@
               <a:buNone/>
             </a:pPr>
             <a:r>
-              <a:rPr lang="fr-FR"/>
+              <a:rPr lang="fr-FR" dirty="0"/>
               <a:t>. Déménagement</a:t>
             </a:r>
           </a:p>
@@ -9102,7 +8853,7 @@
               <a:buNone/>
             </a:pPr>
             <a:r>
-              <a:rPr lang="fr-FR"/>
+              <a:rPr lang="fr-FR" dirty="0"/>
               <a:t>. Lavage voiture</a:t>
             </a:r>
           </a:p>
@@ -9110,7 +8861,7 @@
             <a:pPr marL="0" indent="0">
               <a:buNone/>
             </a:pPr>
-            <a:endParaRPr lang="fr-FR"/>
+            <a:endParaRPr lang="fr-FR" dirty="0"/>
           </a:p>
         </p:txBody>
       </p:sp>

</xml_diff>